<commit_message>
Harden biometric auth: add SD1/SD2/LF-HF features, raise threshold to 0.90, clean dead code
- ECG feature vector expanded 7→10: SD1, SD2 (Poincaré) and LF/HF ratio (frequency domain) added to reduce false-accept rate between operators
- Authentication threshold raised 0.85→0.90 for stricter inter-subject discrimination
- FEATURE_SCALES updated for new 17-element biometric vector
- Removed unused sys import, get_current_hr, gps field from DRONE_STATES
- Presentation updated: Defence Track only on title slide

Co-Authored-By: Claude Sonnet 4.6 <noreply@anthropic.com>
</commit_message>
<xml_diff>
--- a/BioKey_Presentation.pptx
+++ b/BioKey_Presentation.pptx
@@ -3370,7 +3370,7 @@
                 </a:solidFill>
                 <a:latin typeface="Courier New"/>
               </a:rPr>
-              <a:t>HackTM 2026   //   Defence Track   //   Product Innovation Track</a:t>
+              <a:t>HackTM 2026   //   Defence Track</a:t>
             </a:r>
           </a:p>
         </p:txBody>
@@ -3399,13 +3399,13 @@
           <a:p>
             <a:pPr algn="l"/>
             <a:r>
-              <a:rPr sz="1400" b="0" i="0">
+              <a:rPr sz="1200" b="0" i="0">
                 <a:solidFill>
                   <a:srgbClr val="6AAA6A"/>
                 </a:solidFill>
                 <a:latin typeface="Courier New"/>
               </a:rPr>
-              <a:t>Iosif Sramec   //   UPT AC</a:t>
+              <a:t>Jigmond Alexandru   ·   Milotin Rareș   ·   Sramec Iosif   ·   Stan Cristian     //     UPT AC</a:t>
             </a:r>
           </a:p>
         </p:txBody>

</xml_diff>

<commit_message>
Restructure presentation: 4 slides, problem/cause/comparison/closing
Co-Authored-By: Claude Sonnet 4.6 <noreply@anthropic.com>
</commit_message>
<xml_diff>
--- a/BioKey_Presentation.pptx
+++ b/BioKey_Presentation.pptx
@@ -3215,7 +3215,7 @@
                 </a:solidFill>
                 <a:latin typeface="Courier New"/>
               </a:rPr>
-              <a:t>// BIOKEY SYSTEM v2.0</a:t>
+              <a:t>// BIOKEY</a:t>
             </a:r>
           </a:p>
         </p:txBody>
@@ -3229,7 +3229,7 @@
         <p:spPr>
           <a:xfrm>
             <a:off x="640080" y="1188720"/>
-            <a:ext cx="10515600" cy="2377440"/>
+            <a:ext cx="10515600" cy="2560320"/>
           </a:xfrm>
           <a:prstGeom prst="rect">
             <a:avLst/>
@@ -3244,7 +3244,7 @@
           <a:p>
             <a:pPr algn="l"/>
             <a:r>
-              <a:rPr sz="5200" b="1" i="0">
+              <a:rPr sz="5400" b="1" i="0">
                 <a:solidFill>
                   <a:srgbClr val="E8F5E0"/>
                 </a:solidFill>
@@ -3264,7 +3264,7 @@
         </p:nvSpPr>
         <p:spPr>
           <a:xfrm>
-            <a:off x="640080" y="3749039"/>
+            <a:off x="640080" y="3840480"/>
             <a:ext cx="10515600" cy="548640"/>
           </a:xfrm>
           <a:prstGeom prst="rect">
@@ -3280,7 +3280,7 @@
           <a:p>
             <a:pPr algn="l"/>
             <a:r>
-              <a:rPr sz="2000" b="0" i="0">
+              <a:rPr sz="1900" b="0" i="0">
                 <a:solidFill>
                   <a:srgbClr val="4A9A4A"/>
                 </a:solidFill>
@@ -3299,7 +3299,7 @@
         </p:nvSpPr>
         <p:spPr>
           <a:xfrm>
-            <a:off x="0" y="4526280"/>
+            <a:off x="0" y="4572000"/>
             <a:ext cx="12188952" cy="54864"/>
           </a:xfrm>
           <a:prstGeom prst="rect">
@@ -3342,7 +3342,7 @@
         </p:nvSpPr>
         <p:spPr>
           <a:xfrm>
-            <a:off x="640080" y="4709160"/>
+            <a:off x="640080" y="4754880"/>
             <a:ext cx="10972800" cy="411480"/>
           </a:xfrm>
           <a:prstGeom prst="rect">
@@ -3377,7 +3377,7 @@
         </p:nvSpPr>
         <p:spPr>
           <a:xfrm>
-            <a:off x="640080" y="5166360"/>
+            <a:off x="640080" y="5212080"/>
             <a:ext cx="10972800" cy="411480"/>
           </a:xfrm>
           <a:prstGeom prst="rect">
@@ -3503,7 +3503,7 @@
                 </a:solidFill>
                 <a:latin typeface="Courier New"/>
               </a:rPr>
-              <a:t>// 01  PROBLEM</a:t>
+              <a:t>// 01  PROBLEM &amp; CAUSE</a:t>
             </a:r>
           </a:p>
         </p:txBody>
@@ -3517,7 +3517,7 @@
         <p:spPr>
           <a:xfrm>
             <a:off x="640080" y="960120"/>
-            <a:ext cx="10058400" cy="1554480"/>
+            <a:ext cx="10972800" cy="1463040"/>
           </a:xfrm>
           <a:prstGeom prst="rect">
             <a:avLst/>
@@ -3532,13 +3532,13 @@
           <a:p>
             <a:pPr algn="l"/>
             <a:r>
-              <a:rPr sz="4000" b="1" i="0">
+              <a:rPr sz="4200" b="1" i="0">
                 <a:solidFill>
                   <a:srgbClr val="E8F5E0"/>
                 </a:solidFill>
                 <a:latin typeface="Courier New"/>
               </a:rPr>
-              <a:t>Authentication breaks
+              <a:t>Authentication fails
 when it matters most.</a:t>
             </a:r>
           </a:p>
@@ -3546,14 +3546,49 @@
       </p:sp>
       <p:sp>
         <p:nvSpPr>
-          <p:cNvPr id="5" name="Rectangle 4"/>
+          <p:cNvPr id="5" name="TextBox 4"/>
+          <p:cNvSpPr txBox="1"/>
+          <p:nvPr/>
+        </p:nvSpPr>
+        <p:spPr>
+          <a:xfrm>
+            <a:off x="640080" y="2560320"/>
+            <a:ext cx="10972800" cy="457200"/>
+          </a:xfrm>
+          <a:prstGeom prst="rect">
+            <a:avLst/>
+          </a:prstGeom>
+          <a:noFill/>
+        </p:spPr>
+        <p:txBody>
+          <a:bodyPr wrap="square">
+            <a:spAutoFit/>
+          </a:bodyPr>
+          <a:lstStyle/>
+          <a:p>
+            <a:pPr algn="l"/>
+            <a:r>
+              <a:rPr sz="1700" b="0" i="1">
+                <a:solidFill>
+                  <a:srgbClr val="6AAA6A"/>
+                </a:solidFill>
+                <a:latin typeface="Courier New"/>
+              </a:rPr>
+              <a:t>The human body changes under stress. Authentication systems don't.</a:t>
+            </a:r>
+          </a:p>
+        </p:txBody>
+      </p:sp>
+      <p:sp>
+        <p:nvSpPr>
+          <p:cNvPr id="6" name="Rectangle 5"/>
           <p:cNvSpPr/>
           <p:nvPr/>
         </p:nvSpPr>
         <p:spPr>
           <a:xfrm>
-            <a:off x="365760" y="2743200"/>
-            <a:ext cx="2743200" cy="2651760"/>
+            <a:off x="365760" y="3154680"/>
+            <a:ext cx="3657600" cy="2651760"/>
           </a:xfrm>
           <a:prstGeom prst="rect">
             <a:avLst/>
@@ -3591,14 +3626,14 @@
       </p:sp>
       <p:sp>
         <p:nvSpPr>
-          <p:cNvPr id="6" name="TextBox 5"/>
+          <p:cNvPr id="7" name="TextBox 6"/>
           <p:cNvSpPr txBox="1"/>
           <p:nvPr/>
         </p:nvSpPr>
         <p:spPr>
           <a:xfrm>
-            <a:off x="502920" y="2852928"/>
-            <a:ext cx="2514600" cy="365760"/>
+            <a:off x="530352" y="3264408"/>
+            <a:ext cx="3383280" cy="411480"/>
           </a:xfrm>
           <a:prstGeom prst="rect">
             <a:avLst/>
@@ -3619,21 +3654,21 @@
                 </a:solidFill>
                 <a:latin typeface="Courier New"/>
               </a:rPr>
-              <a:t>STRESS</a:t>
-            </a:r>
-          </a:p>
-        </p:txBody>
-      </p:sp>
-      <p:sp>
-        <p:nvSpPr>
-          <p:cNvPr id="7" name="TextBox 6"/>
+              <a:t>STRESS CHANGES THE BODY</a:t>
+            </a:r>
+          </a:p>
+        </p:txBody>
+      </p:sp>
+      <p:sp>
+        <p:nvSpPr>
+          <p:cNvPr id="8" name="TextBox 7"/>
           <p:cNvSpPr txBox="1"/>
           <p:nvPr/>
         </p:nvSpPr>
         <p:spPr>
           <a:xfrm>
-            <a:off x="502920" y="3310128"/>
-            <a:ext cx="2514600" cy="1828800"/>
+            <a:off x="530352" y="3794760"/>
+            <a:ext cx="3383280" cy="1828800"/>
           </a:xfrm>
           <a:prstGeom prst="rect">
             <a:avLst/>
@@ -3648,14 +3683,14 @@
           <a:p>
             <a:pPr algn="l"/>
             <a:r>
-              <a:rPr sz="1300" b="0" i="0">
+              <a:rPr sz="1400" b="0" i="0">
                 <a:solidFill>
                   <a:srgbClr val="6AAA6A"/>
                 </a:solidFill>
                 <a:latin typeface="Courier New"/>
               </a:rPr>
-              <a:t>A soldier's ECG at 70 bpm
-is not the same at 160 bpm.
+              <a:t>HR: 70 bpm → 160 bpm
+ECG enrolled at rest fails in the field.
 The system denies its own operator.</a:t>
             </a:r>
           </a:p>
@@ -3663,14 +3698,14 @@
       </p:sp>
       <p:sp>
         <p:nvSpPr>
-          <p:cNvPr id="8" name="Rectangle 7"/>
+          <p:cNvPr id="9" name="Rectangle 8"/>
           <p:cNvSpPr/>
           <p:nvPr/>
         </p:nvSpPr>
         <p:spPr>
           <a:xfrm>
-            <a:off x="3246120" y="2743200"/>
-            <a:ext cx="2743200" cy="2651760"/>
+            <a:off x="4297680" y="3154680"/>
+            <a:ext cx="3657600" cy="2651760"/>
           </a:xfrm>
           <a:prstGeom prst="rect">
             <a:avLst/>
@@ -3708,14 +3743,14 @@
       </p:sp>
       <p:sp>
         <p:nvSpPr>
-          <p:cNvPr id="9" name="TextBox 8"/>
+          <p:cNvPr id="10" name="TextBox 9"/>
           <p:cNvSpPr txBox="1"/>
           <p:nvPr/>
         </p:nvSpPr>
         <p:spPr>
           <a:xfrm>
-            <a:off x="3383279" y="2852928"/>
-            <a:ext cx="2514600" cy="365760"/>
+            <a:off x="4462272" y="3264408"/>
+            <a:ext cx="3383280" cy="411480"/>
           </a:xfrm>
           <a:prstGeom prst="rect">
             <a:avLst/>
@@ -3736,21 +3771,21 @@
                 </a:solidFill>
                 <a:latin typeface="Courier New"/>
               </a:rPr>
-              <a:t>CAPTURE</a:t>
-            </a:r>
-          </a:p>
-        </p:txBody>
-      </p:sp>
-      <p:sp>
-        <p:nvSpPr>
-          <p:cNvPr id="10" name="TextBox 9"/>
+              <a:t>CAPTURED HARDWARE</a:t>
+            </a:r>
+          </a:p>
+        </p:txBody>
+      </p:sp>
+      <p:sp>
+        <p:nvSpPr>
+          <p:cNvPr id="11" name="TextBox 10"/>
           <p:cNvSpPr txBox="1"/>
           <p:nvPr/>
         </p:nvSpPr>
         <p:spPr>
           <a:xfrm>
-            <a:off x="3383279" y="3310128"/>
-            <a:ext cx="2514600" cy="1828800"/>
+            <a:off x="4462272" y="3794760"/>
+            <a:ext cx="3383280" cy="1828800"/>
           </a:xfrm>
           <a:prstGeom prst="rect">
             <a:avLst/>
@@ -3765,29 +3800,28 @@
           <a:p>
             <a:pPr algn="l"/>
             <a:r>
-              <a:rPr sz="1300" b="0" i="0">
+              <a:rPr sz="1400" b="0" i="0">
                 <a:solidFill>
                   <a:srgbClr val="6AAA6A"/>
                 </a:solidFill>
                 <a:latin typeface="Courier New"/>
               </a:rPr>
-              <a:t>If the device is seized,
-all onboard data is immediately
-accessible. No cryptographic barrier.</a:t>
-            </a:r>
-          </a:p>
-        </p:txBody>
-      </p:sp>
-      <p:sp>
-        <p:nvSpPr>
-          <p:cNvPr id="11" name="Rectangle 10"/>
+              <a:t>No cryptographic binding to the operator.
+Seized device = immediate data access.</a:t>
+            </a:r>
+          </a:p>
+        </p:txBody>
+      </p:sp>
+      <p:sp>
+        <p:nvSpPr>
+          <p:cNvPr id="12" name="Rectangle 11"/>
           <p:cNvSpPr/>
           <p:nvPr/>
         </p:nvSpPr>
         <p:spPr>
           <a:xfrm>
-            <a:off x="6126480" y="2743200"/>
-            <a:ext cx="2743200" cy="2651760"/>
+            <a:off x="8229600" y="3154680"/>
+            <a:ext cx="3657600" cy="2651760"/>
           </a:xfrm>
           <a:prstGeom prst="rect">
             <a:avLst/>
@@ -3825,14 +3859,14 @@
       </p:sp>
       <p:sp>
         <p:nvSpPr>
-          <p:cNvPr id="12" name="TextBox 11"/>
+          <p:cNvPr id="13" name="TextBox 12"/>
           <p:cNvSpPr txBox="1"/>
           <p:nvPr/>
         </p:nvSpPr>
         <p:spPr>
           <a:xfrm>
-            <a:off x="6263640" y="2852928"/>
-            <a:ext cx="2514600" cy="365760"/>
+            <a:off x="8394192" y="3264408"/>
+            <a:ext cx="3383280" cy="411480"/>
           </a:xfrm>
           <a:prstGeom prst="rect">
             <a:avLst/>
@@ -3860,14 +3894,14 @@
       </p:sp>
       <p:sp>
         <p:nvSpPr>
-          <p:cNvPr id="13" name="TextBox 12"/>
+          <p:cNvPr id="14" name="TextBox 13"/>
           <p:cNvSpPr txBox="1"/>
           <p:nvPr/>
         </p:nvSpPr>
         <p:spPr>
           <a:xfrm>
-            <a:off x="6263640" y="3310128"/>
-            <a:ext cx="2514600" cy="1828800"/>
+            <a:off x="8394192" y="3794760"/>
+            <a:ext cx="3383280" cy="1828800"/>
           </a:xfrm>
           <a:prstGeom prst="rect">
             <a:avLst/>
@@ -3882,14 +3916,13 @@
           <a:p>
             <a:pPr algn="l"/>
             <a:r>
-              <a:rPr sz="1300" b="0" i="0">
+              <a:rPr sz="1400" b="0" i="0">
                 <a:solidFill>
                   <a:srgbClr val="6AAA6A"/>
                 </a:solidFill>
                 <a:latin typeface="Courier New"/>
               </a:rPr>
-              <a:t>Passwords and cards
-can be taken by force.
+              <a:t>Passwords and cards can be taken by force.
 The operator cannot protect them.</a:t>
             </a:r>
           </a:p>
@@ -3897,124 +3930,7 @@
       </p:sp>
       <p:sp>
         <p:nvSpPr>
-          <p:cNvPr id="14" name="Rectangle 13"/>
-          <p:cNvSpPr/>
-          <p:nvPr/>
-        </p:nvSpPr>
-        <p:spPr>
-          <a:xfrm>
-            <a:off x="9006840" y="2743200"/>
-            <a:ext cx="2743200" cy="2651760"/>
-          </a:xfrm>
-          <a:prstGeom prst="rect">
-            <a:avLst/>
-          </a:prstGeom>
-          <a:solidFill>
-            <a:srgbClr val="142A14"/>
-          </a:solidFill>
-          <a:ln w="19050">
-            <a:solidFill>
-              <a:srgbClr val="B91C1C"/>
-            </a:solidFill>
-          </a:ln>
-        </p:spPr>
-        <p:style>
-          <a:lnRef idx="1">
-            <a:schemeClr val="accent1"/>
-          </a:lnRef>
-          <a:fillRef idx="3">
-            <a:schemeClr val="accent1"/>
-          </a:fillRef>
-          <a:effectRef idx="2">
-            <a:schemeClr val="accent1"/>
-          </a:effectRef>
-          <a:fontRef idx="minor">
-            <a:schemeClr val="lt1"/>
-          </a:fontRef>
-        </p:style>
-        <p:txBody>
-          <a:bodyPr rtlCol="0" anchor="ctr"/>
-          <a:lstStyle/>
-          <a:p>
-            <a:pPr algn="ctr"/>
-          </a:p>
-        </p:txBody>
-      </p:sp>
-      <p:sp>
-        <p:nvSpPr>
-          <p:cNvPr id="15" name="TextBox 14"/>
-          <p:cNvSpPr txBox="1"/>
-          <p:nvPr/>
-        </p:nvSpPr>
-        <p:spPr>
-          <a:xfrm>
-            <a:off x="9144000" y="2852928"/>
-            <a:ext cx="2514600" cy="365760"/>
-          </a:xfrm>
-          <a:prstGeom prst="rect">
-            <a:avLst/>
-          </a:prstGeom>
-          <a:noFill/>
-        </p:spPr>
-        <p:txBody>
-          <a:bodyPr wrap="square">
-            <a:spAutoFit/>
-          </a:bodyPr>
-          <a:lstStyle/>
-          <a:p>
-            <a:pPr algn="l"/>
-            <a:r>
-              <a:rPr sz="1100" b="1" i="0">
-                <a:solidFill>
-                  <a:srgbClr val="B91C1C"/>
-                </a:solidFill>
-                <a:latin typeface="Courier New"/>
-              </a:rPr>
-              <a:t>SINGLE TEMPLATE</a:t>
-            </a:r>
-          </a:p>
-        </p:txBody>
-      </p:sp>
-      <p:sp>
-        <p:nvSpPr>
-          <p:cNvPr id="16" name="TextBox 15"/>
-          <p:cNvSpPr txBox="1"/>
-          <p:nvPr/>
-        </p:nvSpPr>
-        <p:spPr>
-          <a:xfrm>
-            <a:off x="9144000" y="3310128"/>
-            <a:ext cx="2514600" cy="1828800"/>
-          </a:xfrm>
-          <a:prstGeom prst="rect">
-            <a:avLst/>
-          </a:prstGeom>
-          <a:noFill/>
-        </p:spPr>
-        <p:txBody>
-          <a:bodyPr wrap="square">
-            <a:spAutoFit/>
-          </a:bodyPr>
-          <a:lstStyle/>
-          <a:p>
-            <a:pPr algn="l"/>
-            <a:r>
-              <a:rPr sz="1300" b="0" i="0">
-                <a:solidFill>
-                  <a:srgbClr val="6AAA6A"/>
-                </a:solidFill>
-                <a:latin typeface="Courier New"/>
-              </a:rPr>
-              <a:t>Every existing biometric system
-enrolls once, at rest.
-Field conditions break the assumption.</a:t>
-            </a:r>
-          </a:p>
-        </p:txBody>
-      </p:sp>
-      <p:sp>
-        <p:nvSpPr>
-          <p:cNvPr id="17" name="Rectangle 16"/>
+          <p:cNvPr id="15" name="Rectangle 14"/>
           <p:cNvSpPr/>
           <p:nvPr/>
         </p:nvSpPr>
@@ -4154,7 +4070,7 @@
                 </a:solidFill>
                 <a:latin typeface="Courier New"/>
               </a:rPr>
-              <a:t>// 02  SOLUTION</a:t>
+              <a:t>// 02  EXISTING SOLUTIONS vs BIOKEY</a:t>
             </a:r>
           </a:p>
         </p:txBody>
@@ -4183,14 +4099,14 @@
           <a:p>
             <a:pPr algn="l"/>
             <a:r>
-              <a:rPr sz="3800" b="1" i="0">
+              <a:rPr sz="4000" b="1" i="0">
                 <a:solidFill>
                   <a:srgbClr val="E8F5E0"/>
                 </a:solidFill>
                 <a:latin typeface="Courier New"/>
               </a:rPr>
-              <a:t>Operator-bound encryption.
-Stress-invariant.</a:t>
+              <a:t>Everything leaves a gap.
+We close it.</a:t>
             </a:r>
           </a:p>
         </p:txBody>
@@ -4204,7 +4120,7 @@
         <p:spPr>
           <a:xfrm>
             <a:off x="365760" y="2514600"/>
-            <a:ext cx="11430000" cy="987552"/>
+            <a:ext cx="5394960" cy="3337560"/>
           </a:xfrm>
           <a:prstGeom prst="rect">
             <a:avLst/>
@@ -4214,7 +4130,7 @@
           </a:solidFill>
           <a:ln w="19050">
             <a:solidFill>
-              <a:srgbClr val="4A9A4A"/>
+              <a:srgbClr val="B91C1C"/>
             </a:solidFill>
           </a:ln>
         </p:spPr>
@@ -4248,8 +4164,8 @@
         </p:nvSpPr>
         <p:spPr>
           <a:xfrm>
-            <a:off x="548640" y="2606040"/>
-            <a:ext cx="3200400" cy="320040"/>
+            <a:off x="548640" y="2624328"/>
+            <a:ext cx="5120640" cy="365760"/>
           </a:xfrm>
           <a:prstGeom prst="rect">
             <a:avLst/>
@@ -4266,11 +4182,11 @@
             <a:r>
               <a:rPr sz="1100" b="1" i="0">
                 <a:solidFill>
-                  <a:srgbClr val="4A9A4A"/>
+                  <a:srgbClr val="B91C1C"/>
                 </a:solidFill>
                 <a:latin typeface="Courier New"/>
               </a:rPr>
-              <a:t>MULTI-TEMPLATE ENROLLMENT</a:t>
+              <a:t>WHAT EXISTS</a:t>
             </a:r>
           </a:p>
         </p:txBody>
@@ -4283,8 +4199,8 @@
         </p:nvSpPr>
         <p:spPr>
           <a:xfrm>
-            <a:off x="3931920" y="2606040"/>
-            <a:ext cx="7680960" cy="777240"/>
+            <a:off x="548640" y="3154680"/>
+            <a:ext cx="5120640" cy="548640"/>
           </a:xfrm>
           <a:prstGeom prst="rect">
             <a:avLst/>
@@ -4301,25 +4217,130 @@
             <a:r>
               <a:rPr sz="1400" b="0" i="0">
                 <a:solidFill>
-                  <a:srgbClr val="E8F5E0"/>
+                  <a:srgbClr val="6AAA6A"/>
                 </a:solidFill>
                 <a:latin typeface="Courier New"/>
               </a:rPr>
-              <a:t>The operator is enrolled across 5 physiological states — rest to heavy exertion. The system recognizes them at any heart rate, automatically.</a:t>
-            </a:r>
-          </a:p>
-        </p:txBody>
-      </p:sp>
-      <p:sp>
-        <p:nvSpPr>
-          <p:cNvPr id="8" name="Rectangle 7"/>
+              <a:t>✕  Passwords — coerced or forgotten</a:t>
+            </a:r>
+          </a:p>
+        </p:txBody>
+      </p:sp>
+      <p:sp>
+        <p:nvSpPr>
+          <p:cNvPr id="8" name="TextBox 7"/>
+          <p:cNvSpPr txBox="1"/>
+          <p:nvPr/>
+        </p:nvSpPr>
+        <p:spPr>
+          <a:xfrm>
+            <a:off x="548640" y="3776472"/>
+            <a:ext cx="5120640" cy="548640"/>
+          </a:xfrm>
+          <a:prstGeom prst="rect">
+            <a:avLst/>
+          </a:prstGeom>
+          <a:noFill/>
+        </p:spPr>
+        <p:txBody>
+          <a:bodyPr wrap="square">
+            <a:spAutoFit/>
+          </a:bodyPr>
+          <a:lstStyle/>
+          <a:p>
+            <a:pPr algn="l"/>
+            <a:r>
+              <a:rPr sz="1400" b="0" i="0">
+                <a:solidFill>
+                  <a:srgbClr val="6AAA6A"/>
+                </a:solidFill>
+                <a:latin typeface="Courier New"/>
+              </a:rPr>
+              <a:t>✕  Smart cards — lost or stolen</a:t>
+            </a:r>
+          </a:p>
+        </p:txBody>
+      </p:sp>
+      <p:sp>
+        <p:nvSpPr>
+          <p:cNvPr id="9" name="TextBox 8"/>
+          <p:cNvSpPr txBox="1"/>
+          <p:nvPr/>
+        </p:nvSpPr>
+        <p:spPr>
+          <a:xfrm>
+            <a:off x="548640" y="4398264"/>
+            <a:ext cx="5120640" cy="548640"/>
+          </a:xfrm>
+          <a:prstGeom prst="rect">
+            <a:avLst/>
+          </a:prstGeom>
+          <a:noFill/>
+        </p:spPr>
+        <p:txBody>
+          <a:bodyPr wrap="square">
+            <a:spAutoFit/>
+          </a:bodyPr>
+          <a:lstStyle/>
+          <a:p>
+            <a:pPr algn="l"/>
+            <a:r>
+              <a:rPr sz="1400" b="0" i="0">
+                <a:solidFill>
+                  <a:srgbClr val="6AAA6A"/>
+                </a:solidFill>
+                <a:latin typeface="Courier New"/>
+              </a:rPr>
+              <a:t>✕  Single biometric template — fails under stress</a:t>
+            </a:r>
+          </a:p>
+        </p:txBody>
+      </p:sp>
+      <p:sp>
+        <p:nvSpPr>
+          <p:cNvPr id="10" name="TextBox 9"/>
+          <p:cNvSpPr txBox="1"/>
+          <p:nvPr/>
+        </p:nvSpPr>
+        <p:spPr>
+          <a:xfrm>
+            <a:off x="548640" y="5020056"/>
+            <a:ext cx="5120640" cy="548640"/>
+          </a:xfrm>
+          <a:prstGeom prst="rect">
+            <a:avLst/>
+          </a:prstGeom>
+          <a:noFill/>
+        </p:spPr>
+        <p:txBody>
+          <a:bodyPr wrap="square">
+            <a:spAutoFit/>
+          </a:bodyPr>
+          <a:lstStyle/>
+          <a:p>
+            <a:pPr algn="l"/>
+            <a:r>
+              <a:rPr sz="1400" b="0" i="0">
+                <a:solidFill>
+                  <a:srgbClr val="6AAA6A"/>
+                </a:solidFill>
+                <a:latin typeface="Courier New"/>
+              </a:rPr>
+              <a:t>✕  Hardware encryption — key tied to device, not operator</a:t>
+            </a:r>
+          </a:p>
+        </p:txBody>
+      </p:sp>
+      <p:sp>
+        <p:nvSpPr>
+          <p:cNvPr id="11" name="Rectangle 10"/>
           <p:cNvSpPr/>
           <p:nvPr/>
         </p:nvSpPr>
         <p:spPr>
           <a:xfrm>
-            <a:off x="365760" y="3630168"/>
-            <a:ext cx="11430000" cy="987552"/>
+            <a:off x="6400800" y="2514600"/>
+            <a:ext cx="5394960" cy="3337560"/>
           </a:xfrm>
           <a:prstGeom prst="rect">
             <a:avLst/>
@@ -4327,7 +4348,7 @@
           <a:solidFill>
             <a:srgbClr val="142A14"/>
           </a:solidFill>
-          <a:ln w="19050">
+          <a:ln w="25400">
             <a:solidFill>
               <a:srgbClr val="4A9A4A"/>
             </a:solidFill>
@@ -4357,14 +4378,14 @@
       </p:sp>
       <p:sp>
         <p:nvSpPr>
-          <p:cNvPr id="9" name="TextBox 8"/>
+          <p:cNvPr id="12" name="TextBox 11"/>
           <p:cNvSpPr txBox="1"/>
           <p:nvPr/>
         </p:nvSpPr>
         <p:spPr>
           <a:xfrm>
-            <a:off x="548640" y="3721607"/>
-            <a:ext cx="3200400" cy="320040"/>
+            <a:off x="6583680" y="2624328"/>
+            <a:ext cx="5120640" cy="365760"/>
           </a:xfrm>
           <a:prstGeom prst="rect">
             <a:avLst/>
@@ -4385,21 +4406,21 @@
                 </a:solidFill>
                 <a:latin typeface="Courier New"/>
               </a:rPr>
-              <a:t>BIOMETRIC KEY DERIVATION</a:t>
-            </a:r>
-          </a:p>
-        </p:txBody>
-      </p:sp>
-      <p:sp>
-        <p:nvSpPr>
-          <p:cNvPr id="10" name="TextBox 9"/>
+              <a:t>BIOKEY</a:t>
+            </a:r>
+          </a:p>
+        </p:txBody>
+      </p:sp>
+      <p:sp>
+        <p:nvSpPr>
+          <p:cNvPr id="13" name="TextBox 12"/>
           <p:cNvSpPr txBox="1"/>
           <p:nvPr/>
         </p:nvSpPr>
         <p:spPr>
           <a:xfrm>
-            <a:off x="3931920" y="3721607"/>
-            <a:ext cx="7680960" cy="777240"/>
+            <a:off x="6583680" y="3154680"/>
+            <a:ext cx="5120640" cy="548640"/>
           </a:xfrm>
           <a:prstGeom prst="rect">
             <a:avLst/>
@@ -4420,101 +4441,21 @@
                 </a:solidFill>
                 <a:latin typeface="Courier New"/>
               </a:rPr>
-              <a:t>The AES-256 encryption key is derived directly from the cardiac signature + PIN. Without the right person, the data is cryptographically inaccessible — not just access-restricted.</a:t>
-            </a:r>
-          </a:p>
-        </p:txBody>
-      </p:sp>
-      <p:sp>
-        <p:nvSpPr>
-          <p:cNvPr id="11" name="Rectangle 10"/>
-          <p:cNvSpPr/>
-          <p:nvPr/>
-        </p:nvSpPr>
-        <p:spPr>
-          <a:xfrm>
-            <a:off x="365760" y="4745736"/>
-            <a:ext cx="11430000" cy="987552"/>
-          </a:xfrm>
-          <a:prstGeom prst="rect">
-            <a:avLst/>
-          </a:prstGeom>
-          <a:solidFill>
-            <a:srgbClr val="142A14"/>
-          </a:solidFill>
-          <a:ln w="19050">
-            <a:solidFill>
-              <a:srgbClr val="4A9A4A"/>
-            </a:solidFill>
-          </a:ln>
-        </p:spPr>
-        <p:style>
-          <a:lnRef idx="1">
-            <a:schemeClr val="accent1"/>
-          </a:lnRef>
-          <a:fillRef idx="3">
-            <a:schemeClr val="accent1"/>
-          </a:fillRef>
-          <a:effectRef idx="2">
-            <a:schemeClr val="accent1"/>
-          </a:effectRef>
-          <a:fontRef idx="minor">
-            <a:schemeClr val="lt1"/>
-          </a:fontRef>
-        </p:style>
-        <p:txBody>
-          <a:bodyPr rtlCol="0" anchor="ctr"/>
-          <a:lstStyle/>
-          <a:p>
-            <a:pPr algn="ctr"/>
-          </a:p>
-        </p:txBody>
-      </p:sp>
-      <p:sp>
-        <p:nvSpPr>
-          <p:cNvPr id="12" name="TextBox 11"/>
+              <a:t>✓  5 templates — covers all stress levels</a:t>
+            </a:r>
+          </a:p>
+        </p:txBody>
+      </p:sp>
+      <p:sp>
+        <p:nvSpPr>
+          <p:cNvPr id="14" name="TextBox 13"/>
           <p:cNvSpPr txBox="1"/>
           <p:nvPr/>
         </p:nvSpPr>
         <p:spPr>
           <a:xfrm>
-            <a:off x="548640" y="4837175"/>
-            <a:ext cx="3200400" cy="320040"/>
-          </a:xfrm>
-          <a:prstGeom prst="rect">
-            <a:avLst/>
-          </a:prstGeom>
-          <a:noFill/>
-        </p:spPr>
-        <p:txBody>
-          <a:bodyPr wrap="square">
-            <a:spAutoFit/>
-          </a:bodyPr>
-          <a:lstStyle/>
-          <a:p>
-            <a:pPr algn="l"/>
-            <a:r>
-              <a:rPr sz="1100" b="1" i="0">
-                <a:solidFill>
-                  <a:srgbClr val="4A9A4A"/>
-                </a:solidFill>
-                <a:latin typeface="Courier New"/>
-              </a:rPr>
-              <a:t>SECOND FACTOR — PIN</a:t>
-            </a:r>
-          </a:p>
-        </p:txBody>
-      </p:sp>
-      <p:sp>
-        <p:nvSpPr>
-          <p:cNvPr id="13" name="TextBox 12"/>
-          <p:cNvSpPr txBox="1"/>
-          <p:nvPr/>
-        </p:nvSpPr>
-        <p:spPr>
-          <a:xfrm>
-            <a:off x="3931920" y="4837175"/>
-            <a:ext cx="7680960" cy="777240"/>
+            <a:off x="6583680" y="3776472"/>
+            <a:ext cx="5120640" cy="548640"/>
           </a:xfrm>
           <a:prstGeom prst="rect">
             <a:avLst/>
@@ -4535,14 +4476,84 @@
                 </a:solidFill>
                 <a:latin typeface="Courier New"/>
               </a:rPr>
-              <a:t>Even with correct biometrics, a wrong PIN fails at the cryptographic level. Captured biometric data alone is not enough.</a:t>
-            </a:r>
-          </a:p>
-        </p:txBody>
-      </p:sp>
-      <p:sp>
-        <p:nvSpPr>
-          <p:cNvPr id="14" name="Rectangle 13"/>
+              <a:t>✓  Key derived from biometrics — not stored</a:t>
+            </a:r>
+          </a:p>
+        </p:txBody>
+      </p:sp>
+      <p:sp>
+        <p:nvSpPr>
+          <p:cNvPr id="15" name="TextBox 14"/>
+          <p:cNvSpPr txBox="1"/>
+          <p:nvPr/>
+        </p:nvSpPr>
+        <p:spPr>
+          <a:xfrm>
+            <a:off x="6583680" y="4398264"/>
+            <a:ext cx="5120640" cy="548640"/>
+          </a:xfrm>
+          <a:prstGeom prst="rect">
+            <a:avLst/>
+          </a:prstGeom>
+          <a:noFill/>
+        </p:spPr>
+        <p:txBody>
+          <a:bodyPr wrap="square">
+            <a:spAutoFit/>
+          </a:bodyPr>
+          <a:lstStyle/>
+          <a:p>
+            <a:pPr algn="l"/>
+            <a:r>
+              <a:rPr sz="1400" b="0" i="0">
+                <a:solidFill>
+                  <a:srgbClr val="E8F5E0"/>
+                </a:solidFill>
+                <a:latin typeface="Courier New"/>
+              </a:rPr>
+              <a:t>✓  PIN second factor — biometrics alone not enough</a:t>
+            </a:r>
+          </a:p>
+        </p:txBody>
+      </p:sp>
+      <p:sp>
+        <p:nvSpPr>
+          <p:cNvPr id="16" name="TextBox 15"/>
+          <p:cNvSpPr txBox="1"/>
+          <p:nvPr/>
+        </p:nvSpPr>
+        <p:spPr>
+          <a:xfrm>
+            <a:off x="6583680" y="5020056"/>
+            <a:ext cx="5120640" cy="548640"/>
+          </a:xfrm>
+          <a:prstGeom prst="rect">
+            <a:avLst/>
+          </a:prstGeom>
+          <a:noFill/>
+        </p:spPr>
+        <p:txBody>
+          <a:bodyPr wrap="square">
+            <a:spAutoFit/>
+          </a:bodyPr>
+          <a:lstStyle/>
+          <a:p>
+            <a:pPr algn="l"/>
+            <a:r>
+              <a:rPr sz="1400" b="0" i="0">
+                <a:solidFill>
+                  <a:srgbClr val="E8F5E0"/>
+                </a:solidFill>
+                <a:latin typeface="Courier New"/>
+              </a:rPr>
+              <a:t>✓  Captured hardware = only ciphertext</a:t>
+            </a:r>
+          </a:p>
+        </p:txBody>
+      </p:sp>
+      <p:sp>
+        <p:nvSpPr>
+          <p:cNvPr id="17" name="Rectangle 16"/>
           <p:cNvSpPr/>
           <p:nvPr/>
         </p:nvSpPr>
@@ -4654,96 +4665,23 @@
       </p:sp>
       <p:sp>
         <p:nvSpPr>
-          <p:cNvPr id="3" name="TextBox 2"/>
-          <p:cNvSpPr txBox="1"/>
-          <p:nvPr/>
-        </p:nvSpPr>
-        <p:spPr>
-          <a:xfrm>
-            <a:off x="640080" y="566928"/>
-            <a:ext cx="10972800" cy="365760"/>
-          </a:xfrm>
-          <a:prstGeom prst="rect">
-            <a:avLst/>
-          </a:prstGeom>
-          <a:noFill/>
-        </p:spPr>
-        <p:txBody>
-          <a:bodyPr wrap="square">
-            <a:spAutoFit/>
-          </a:bodyPr>
-          <a:lstStyle/>
-          <a:p>
-            <a:pPr algn="l"/>
-            <a:r>
-              <a:rPr sz="1200" b="0" i="0">
-                <a:solidFill>
-                  <a:srgbClr val="6AAA6A"/>
-                </a:solidFill>
-                <a:latin typeface="Courier New"/>
-              </a:rPr>
-              <a:t>// 03  IMPACT &amp; SCALABILITY</a:t>
-            </a:r>
-          </a:p>
-        </p:txBody>
-      </p:sp>
-      <p:sp>
-        <p:nvSpPr>
-          <p:cNvPr id="4" name="TextBox 3"/>
-          <p:cNvSpPr txBox="1"/>
-          <p:nvPr/>
-        </p:nvSpPr>
-        <p:spPr>
-          <a:xfrm>
-            <a:off x="640080" y="960120"/>
-            <a:ext cx="10058400" cy="1280160"/>
-          </a:xfrm>
-          <a:prstGeom prst="rect">
-            <a:avLst/>
-          </a:prstGeom>
-          <a:noFill/>
-        </p:spPr>
-        <p:txBody>
-          <a:bodyPr wrap="square">
-            <a:spAutoFit/>
-          </a:bodyPr>
-          <a:lstStyle/>
-          <a:p>
-            <a:pPr algn="l"/>
-            <a:r>
-              <a:rPr sz="3400" b="1" i="0">
-                <a:solidFill>
-                  <a:srgbClr val="E8F5E0"/>
-                </a:solidFill>
-                <a:latin typeface="Courier New"/>
-              </a:rPr>
-              <a:t>Any role where the right person
-must be at the controls — right now.</a:t>
-            </a:r>
-          </a:p>
-        </p:txBody>
-      </p:sp>
-      <p:sp>
-        <p:nvSpPr>
-          <p:cNvPr id="5" name="Rectangle 4"/>
+          <p:cNvPr id="3" name="Rectangle 2"/>
           <p:cNvSpPr/>
           <p:nvPr/>
         </p:nvSpPr>
         <p:spPr>
           <a:xfrm>
-            <a:off x="365760" y="2468880"/>
-            <a:ext cx="5394960" cy="3474720"/>
+            <a:off x="0" y="6263640"/>
+            <a:ext cx="12188952" cy="36576"/>
           </a:xfrm>
           <a:prstGeom prst="rect">
             <a:avLst/>
           </a:prstGeom>
           <a:solidFill>
-            <a:srgbClr val="142A14"/>
+            <a:srgbClr val="4A9A4A"/>
           </a:solidFill>
-          <a:ln w="15240">
-            <a:solidFill>
-              <a:srgbClr val="4A9A4A"/>
-            </a:solidFill>
+          <a:ln>
+            <a:noFill/>
           </a:ln>
         </p:spPr>
         <p:style>
@@ -4770,14 +4708,14 @@
       </p:sp>
       <p:sp>
         <p:nvSpPr>
-          <p:cNvPr id="6" name="TextBox 5"/>
+          <p:cNvPr id="4" name="TextBox 3"/>
           <p:cNvSpPr txBox="1"/>
           <p:nvPr/>
         </p:nvSpPr>
         <p:spPr>
           <a:xfrm>
-            <a:off x="548640" y="2578608"/>
-            <a:ext cx="5120640" cy="365760"/>
+            <a:off x="640080" y="914400"/>
+            <a:ext cx="10972800" cy="3108960"/>
           </a:xfrm>
           <a:prstGeom prst="rect">
             <a:avLst/>
@@ -4790,180 +4728,39 @@
           </a:bodyPr>
           <a:lstStyle/>
           <a:p>
-            <a:pPr algn="l"/>
-            <a:r>
-              <a:rPr sz="1200" b="1" i="0">
-                <a:solidFill>
-                  <a:srgbClr val="B91C1C"/>
-                </a:solidFill>
-                <a:latin typeface="Courier New"/>
-              </a:rPr>
-              <a:t>DEFENCE</a:t>
-            </a:r>
-          </a:p>
-        </p:txBody>
-      </p:sp>
-      <p:sp>
-        <p:nvSpPr>
-          <p:cNvPr id="7" name="TextBox 6"/>
-          <p:cNvSpPr txBox="1"/>
-          <p:nvPr/>
-        </p:nvSpPr>
-        <p:spPr>
-          <a:xfrm>
-            <a:off x="548640" y="3090672"/>
-            <a:ext cx="5120640" cy="457200"/>
-          </a:xfrm>
-          <a:prstGeom prst="rect">
-            <a:avLst/>
-          </a:prstGeom>
-          <a:noFill/>
-        </p:spPr>
-        <p:txBody>
-          <a:bodyPr wrap="square">
-            <a:spAutoFit/>
-          </a:bodyPr>
-          <a:lstStyle/>
-          <a:p>
-            <a:pPr algn="l"/>
-            <a:r>
-              <a:rPr sz="1500" b="0" i="0">
+            <a:pPr algn="ctr"/>
+            <a:r>
+              <a:rPr sz="5600" b="1" i="1">
                 <a:solidFill>
                   <a:srgbClr val="E8F5E0"/>
                 </a:solidFill>
                 <a:latin typeface="Courier New"/>
               </a:rPr>
-              <a:t>→  Drone operator authentication</a:t>
-            </a:r>
-          </a:p>
-        </p:txBody>
-      </p:sp>
-      <p:sp>
-        <p:nvSpPr>
-          <p:cNvPr id="8" name="TextBox 7"/>
-          <p:cNvSpPr txBox="1"/>
-          <p:nvPr/>
-        </p:nvSpPr>
-        <p:spPr>
-          <a:xfrm>
-            <a:off x="548640" y="3593591"/>
-            <a:ext cx="5120640" cy="457200"/>
-          </a:xfrm>
-          <a:prstGeom prst="rect">
-            <a:avLst/>
-          </a:prstGeom>
-          <a:noFill/>
-        </p:spPr>
-        <p:txBody>
-          <a:bodyPr wrap="square">
-            <a:spAutoFit/>
-          </a:bodyPr>
-          <a:lstStyle/>
-          <a:p>
-            <a:pPr algn="l"/>
-            <a:r>
-              <a:rPr sz="1500" b="0" i="0">
-                <a:solidFill>
-                  <a:srgbClr val="E8F5E0"/>
-                </a:solidFill>
-                <a:latin typeface="Courier New"/>
-              </a:rPr>
-              <a:t>→  Forward operating base access</a:t>
-            </a:r>
-          </a:p>
-        </p:txBody>
-      </p:sp>
-      <p:sp>
-        <p:nvSpPr>
-          <p:cNvPr id="9" name="TextBox 8"/>
-          <p:cNvSpPr txBox="1"/>
-          <p:nvPr/>
-        </p:nvSpPr>
-        <p:spPr>
-          <a:xfrm>
-            <a:off x="548640" y="4096512"/>
-            <a:ext cx="5120640" cy="457200"/>
-          </a:xfrm>
-          <a:prstGeom prst="rect">
-            <a:avLst/>
-          </a:prstGeom>
-          <a:noFill/>
-        </p:spPr>
-        <p:txBody>
-          <a:bodyPr wrap="square">
-            <a:spAutoFit/>
-          </a:bodyPr>
-          <a:lstStyle/>
-          <a:p>
-            <a:pPr algn="l"/>
-            <a:r>
-              <a:rPr sz="1500" b="0" i="0">
-                <a:solidFill>
-                  <a:srgbClr val="E8F5E0"/>
-                </a:solidFill>
-                <a:latin typeface="Courier New"/>
-              </a:rPr>
-              <a:t>→  Classified device protection</a:t>
-            </a:r>
-          </a:p>
-        </p:txBody>
-      </p:sp>
-      <p:sp>
-        <p:nvSpPr>
-          <p:cNvPr id="10" name="TextBox 9"/>
-          <p:cNvSpPr txBox="1"/>
-          <p:nvPr/>
-        </p:nvSpPr>
-        <p:spPr>
-          <a:xfrm>
-            <a:off x="548640" y="4599432"/>
-            <a:ext cx="5120640" cy="457200"/>
-          </a:xfrm>
-          <a:prstGeom prst="rect">
-            <a:avLst/>
-          </a:prstGeom>
-          <a:noFill/>
-        </p:spPr>
-        <p:txBody>
-          <a:bodyPr wrap="square">
-            <a:spAutoFit/>
-          </a:bodyPr>
-          <a:lstStyle/>
-          <a:p>
-            <a:pPr algn="l"/>
-            <a:r>
-              <a:rPr sz="1500" b="0" i="0">
-                <a:solidFill>
-                  <a:srgbClr val="E8F5E0"/>
-                </a:solidFill>
-                <a:latin typeface="Courier New"/>
-              </a:rPr>
-              <a:t>→  Two-man rule implementation</a:t>
-            </a:r>
-          </a:p>
-        </p:txBody>
-      </p:sp>
-      <p:sp>
-        <p:nvSpPr>
-          <p:cNvPr id="11" name="Rectangle 10"/>
+              <a:t>"We are the key
+to your heartbeat."</a:t>
+            </a:r>
+          </a:p>
+        </p:txBody>
+      </p:sp>
+      <p:sp>
+        <p:nvSpPr>
+          <p:cNvPr id="5" name="Rectangle 4"/>
           <p:cNvSpPr/>
           <p:nvPr/>
         </p:nvSpPr>
         <p:spPr>
           <a:xfrm>
-            <a:off x="6309360" y="2468880"/>
-            <a:ext cx="5394960" cy="3474720"/>
+            <a:off x="0" y="4343400"/>
+            <a:ext cx="12188952" cy="45720"/>
           </a:xfrm>
           <a:prstGeom prst="rect">
             <a:avLst/>
           </a:prstGeom>
           <a:solidFill>
-            <a:srgbClr val="142A14"/>
+            <a:srgbClr val="1A351A"/>
           </a:solidFill>
-          <a:ln w="19050">
-            <a:solidFill>
-              <a:srgbClr val="4A9A4A"/>
-            </a:solidFill>
+          <a:ln>
+            <a:noFill/>
           </a:ln>
         </p:spPr>
         <p:style>
@@ -4990,14 +4787,14 @@
       </p:sp>
       <p:sp>
         <p:nvSpPr>
-          <p:cNvPr id="12" name="TextBox 11"/>
+          <p:cNvPr id="6" name="TextBox 5"/>
           <p:cNvSpPr txBox="1"/>
           <p:nvPr/>
         </p:nvSpPr>
         <p:spPr>
           <a:xfrm>
-            <a:off x="6492240" y="2578608"/>
-            <a:ext cx="5120640" cy="365760"/>
+            <a:off x="640080" y="4526280"/>
+            <a:ext cx="10972800" cy="457200"/>
           </a:xfrm>
           <a:prstGeom prst="rect">
             <a:avLst/>
@@ -5010,29 +4807,29 @@
           </a:bodyPr>
           <a:lstStyle/>
           <a:p>
-            <a:pPr algn="l"/>
-            <a:r>
-              <a:rPr sz="1200" b="1" i="0">
+            <a:pPr algn="ctr"/>
+            <a:r>
+              <a:rPr sz="1500" b="0" i="0">
                 <a:solidFill>
                   <a:srgbClr val="4A9A4A"/>
                 </a:solidFill>
                 <a:latin typeface="Courier New"/>
               </a:rPr>
-              <a:t>CIVIL &amp; INDUSTRIAL</a:t>
-            </a:r>
-          </a:p>
-        </p:txBody>
-      </p:sp>
-      <p:sp>
-        <p:nvSpPr>
-          <p:cNvPr id="13" name="TextBox 12"/>
+              <a:t>AES-256-GCM   ·   HKDF-SHA256   ·   Multi-Template HRV   ·   PIN Second Factor</a:t>
+            </a:r>
+          </a:p>
+        </p:txBody>
+      </p:sp>
+      <p:sp>
+        <p:nvSpPr>
+          <p:cNvPr id="7" name="TextBox 6"/>
           <p:cNvSpPr txBox="1"/>
           <p:nvPr/>
         </p:nvSpPr>
         <p:spPr>
           <a:xfrm>
-            <a:off x="6492240" y="3090672"/>
-            <a:ext cx="5120640" cy="457200"/>
+            <a:off x="640080" y="5120640"/>
+            <a:ext cx="10972800" cy="411480"/>
           </a:xfrm>
           <a:prstGeom prst="rect">
             <a:avLst/>
@@ -5045,199 +4842,51 @@
           </a:bodyPr>
           <a:lstStyle/>
           <a:p>
-            <a:pPr algn="l"/>
-            <a:r>
-              <a:rPr sz="1500" b="0" i="0">
-                <a:solidFill>
-                  <a:srgbClr val="E8F5E0"/>
-                </a:solidFill>
-                <a:latin typeface="Courier New"/>
-              </a:rPr>
-              <a:t>→  Critical infrastructure access</a:t>
-            </a:r>
-          </a:p>
-        </p:txBody>
-      </p:sp>
-      <p:sp>
-        <p:nvSpPr>
-          <p:cNvPr id="14" name="TextBox 13"/>
-          <p:cNvSpPr txBox="1"/>
-          <p:nvPr/>
-        </p:nvSpPr>
-        <p:spPr>
-          <a:xfrm>
-            <a:off x="6492240" y="3593591"/>
-            <a:ext cx="5120640" cy="457200"/>
-          </a:xfrm>
-          <a:prstGeom prst="rect">
-            <a:avLst/>
-          </a:prstGeom>
-          <a:noFill/>
-        </p:spPr>
-        <p:txBody>
-          <a:bodyPr wrap="square">
-            <a:spAutoFit/>
-          </a:bodyPr>
-          <a:lstStyle/>
-          <a:p>
-            <a:pPr algn="l"/>
-            <a:r>
-              <a:rPr sz="1500" b="0" i="0">
-                <a:solidFill>
-                  <a:srgbClr val="E8F5E0"/>
-                </a:solidFill>
-                <a:latin typeface="Courier New"/>
-              </a:rPr>
-              <a:t>→  Air traffic controller verification</a:t>
-            </a:r>
-          </a:p>
-        </p:txBody>
-      </p:sp>
-      <p:sp>
-        <p:nvSpPr>
-          <p:cNvPr id="15" name="TextBox 14"/>
-          <p:cNvSpPr txBox="1"/>
-          <p:nvPr/>
-        </p:nvSpPr>
-        <p:spPr>
-          <a:xfrm>
-            <a:off x="6492240" y="4096512"/>
-            <a:ext cx="5120640" cy="457200"/>
-          </a:xfrm>
-          <a:prstGeom prst="rect">
-            <a:avLst/>
-          </a:prstGeom>
-          <a:noFill/>
-        </p:spPr>
-        <p:txBody>
-          <a:bodyPr wrap="square">
-            <a:spAutoFit/>
-          </a:bodyPr>
-          <a:lstStyle/>
-          <a:p>
-            <a:pPr algn="l"/>
-            <a:r>
-              <a:rPr sz="1500" b="0" i="0">
-                <a:solidFill>
-                  <a:srgbClr val="E8F5E0"/>
-                </a:solidFill>
-                <a:latin typeface="Courier New"/>
-              </a:rPr>
-              <a:t>→  Nuclear plant operator auth</a:t>
-            </a:r>
-          </a:p>
-        </p:txBody>
-      </p:sp>
-      <p:sp>
-        <p:nvSpPr>
-          <p:cNvPr id="16" name="TextBox 15"/>
-          <p:cNvSpPr txBox="1"/>
-          <p:nvPr/>
-        </p:nvSpPr>
-        <p:spPr>
-          <a:xfrm>
-            <a:off x="6492240" y="4599432"/>
-            <a:ext cx="5120640" cy="457200"/>
-          </a:xfrm>
-          <a:prstGeom prst="rect">
-            <a:avLst/>
-          </a:prstGeom>
-          <a:noFill/>
-        </p:spPr>
-        <p:txBody>
-          <a:bodyPr wrap="square">
-            <a:spAutoFit/>
-          </a:bodyPr>
-          <a:lstStyle/>
-          <a:p>
-            <a:pPr algn="l"/>
-            <a:r>
-              <a:rPr sz="1500" b="0" i="0">
-                <a:solidFill>
-                  <a:srgbClr val="E8F5E0"/>
-                </a:solidFill>
-                <a:latin typeface="Courier New"/>
-              </a:rPr>
-              <a:t>→  Surgeon / operating room control</a:t>
-            </a:r>
-          </a:p>
-        </p:txBody>
-      </p:sp>
-      <p:sp>
-        <p:nvSpPr>
-          <p:cNvPr id="17" name="TextBox 16"/>
-          <p:cNvSpPr txBox="1"/>
-          <p:nvPr/>
-        </p:nvSpPr>
-        <p:spPr>
-          <a:xfrm>
-            <a:off x="640080" y="6016752"/>
-            <a:ext cx="10972800" cy="320040"/>
-          </a:xfrm>
-          <a:prstGeom prst="rect">
-            <a:avLst/>
-          </a:prstGeom>
-          <a:noFill/>
-        </p:spPr>
-        <p:txBody>
-          <a:bodyPr wrap="square">
-            <a:spAutoFit/>
-          </a:bodyPr>
-          <a:lstStyle/>
-          <a:p>
-            <a:pPr algn="l"/>
-            <a:r>
-              <a:rPr sz="1200" b="0" i="1">
+            <a:pPr algn="ctr"/>
+            <a:r>
+              <a:rPr sz="1400" b="0" i="0">
                 <a:solidFill>
                   <a:srgbClr val="6AAA6A"/>
                 </a:solidFill>
                 <a:latin typeface="Courier New"/>
               </a:rPr>
-              <a:t>Cryptographic layer is production-ready.  Path to deployment: TPM/HSM integration — no fundamental blockers.</a:t>
-            </a:r>
-          </a:p>
-        </p:txBody>
-      </p:sp>
-      <p:sp>
-        <p:nvSpPr>
-          <p:cNvPr id="18" name="Rectangle 17"/>
-          <p:cNvSpPr/>
+              <a:t>github.com/IosifSramec/biokey</a:t>
+            </a:r>
+          </a:p>
+        </p:txBody>
+      </p:sp>
+      <p:sp>
+        <p:nvSpPr>
+          <p:cNvPr id="8" name="TextBox 7"/>
+          <p:cNvSpPr txBox="1"/>
           <p:nvPr/>
         </p:nvSpPr>
         <p:spPr>
           <a:xfrm>
-            <a:off x="0" y="6263640"/>
-            <a:ext cx="12188952" cy="36576"/>
+            <a:off x="640080" y="5577840"/>
+            <a:ext cx="10972800" cy="365760"/>
           </a:xfrm>
           <a:prstGeom prst="rect">
             <a:avLst/>
           </a:prstGeom>
-          <a:solidFill>
-            <a:srgbClr val="4A9A4A"/>
-          </a:solidFill>
-          <a:ln>
-            <a:noFill/>
-          </a:ln>
-        </p:spPr>
-        <p:style>
-          <a:lnRef idx="1">
-            <a:schemeClr val="accent1"/>
-          </a:lnRef>
-          <a:fillRef idx="3">
-            <a:schemeClr val="accent1"/>
-          </a:fillRef>
-          <a:effectRef idx="2">
-            <a:schemeClr val="accent1"/>
-          </a:effectRef>
-          <a:fontRef idx="minor">
-            <a:schemeClr val="lt1"/>
-          </a:fontRef>
-        </p:style>
-        <p:txBody>
-          <a:bodyPr rtlCol="0" anchor="ctr"/>
+          <a:noFill/>
+        </p:spPr>
+        <p:txBody>
+          <a:bodyPr wrap="square">
+            <a:spAutoFit/>
+          </a:bodyPr>
           <a:lstStyle/>
           <a:p>
             <a:pPr algn="ctr"/>
+            <a:r>
+              <a:rPr sz="1300" b="0" i="0">
+                <a:solidFill>
+                  <a:srgbClr val="6AAA6A"/>
+                </a:solidFill>
+                <a:latin typeface="Courier New"/>
+              </a:rPr>
+              <a:t>HackTM 2026   //   Defence Track</a:t>
+            </a:r>
           </a:p>
         </p:txBody>
       </p:sp>

</xml_diff>